<commit_message>
Update project overview presentation
Co-Authored-By: Claude Opus 4.6 <noreply@anthropic.com>
</commit_message>
<xml_diff>
--- a/Klingon_Translator_Overview.pptx
+++ b/Klingon_Translator_Overview.pptx
@@ -1838,7 +1838,29 @@
                 <a:ea typeface="Calibri" pitchFamily="34" charset="-122"/>
                 <a:cs typeface="Calibri" pitchFamily="34" charset="-120"/>
               </a:rPr>
-              <a:t>github.com/joshbrehm • Python 3.12 • PyTorch • Hugging Face Transformers</a:t>
+              <a:t>github.com/crosis19/</a:t>
+            </a:r>
+            <a:r>
+              <a:rPr lang="en-US" sz="1000" dirty="0" err="1">
+                <a:solidFill>
+                  <a:srgbClr val="A0A0B8"/>
+                </a:solidFill>
+                <a:latin typeface="Calibri" pitchFamily="34" charset="0"/>
+                <a:ea typeface="Calibri" pitchFamily="34" charset="-122"/>
+                <a:cs typeface="Calibri" pitchFamily="34" charset="-120"/>
+              </a:rPr>
+              <a:t>klingon</a:t>
+            </a:r>
+            <a:r>
+              <a:rPr lang="en-US" sz="1000" dirty="0">
+                <a:solidFill>
+                  <a:srgbClr val="A0A0B8"/>
+                </a:solidFill>
+                <a:latin typeface="Calibri" pitchFamily="34" charset="0"/>
+                <a:ea typeface="Calibri" pitchFamily="34" charset="-122"/>
+                <a:cs typeface="Calibri" pitchFamily="34" charset="-120"/>
+              </a:rPr>
+              <a:t>-translator • Python 3.12 • PyTorch • Hugging Face Transformers</a:t>
             </a:r>
             <a:endParaRPr lang="en-US" sz="1000" dirty="0"/>
           </a:p>

</xml_diff>